<commit_message>
Slop pass over the joint deck's slide text and the manuscript prose
Deck: two punchline titles rewritten as plain statements, one colon reveal and one "measured, not assumed" contrast rewritten, "truly worst quarter" made "the survey's worst quarter", the targeting title shortened to fit. Manuscript: nine sentences with "X, not Y" contrasts, a trailing -ing clause, empty "actually", and one cute lead-in rewritten as plain statements. Both re-rendered.

Co-Authored-By: Claude Fable 5.1 <noreply@anthropic.com>
</commit_message>
<xml_diff>
--- a/docs/slides/MN-proxy-policy-deck-2026-09.pptx
+++ b/docs/slides/MN-proxy-policy-deck-2026-09.pptx
@@ -1692,7 +1692,7 @@
             </a:pPr>
             <a:r>
               <a:rPr/>
-              <a:t>The score is ranking accuracy: how closely the model’s order of districts matches the survey’s, from 0 to 1. One split on its own can move a result by 0.1, so everything is averaged over repeated splits. Plainer versions of the same accuracy are in the appendix: of the truly worst quarter of districts the model finds 43% (a random pick finds 25%), and it places a district in the correct WHO vitamin A band 64% of the time, within one band 92%. The ceiling: most districts hold one or two survey clusters, so the survey’s own district value is itself an estimate; from the variance components we can say what correlation a perfect predictor of the true district value could reach (variance_components_ceiling.csv, ceiling_vc). On the biomarker level the ceiling is about 0.56 and the model reaches 0.40; on prevalence 0.44 and 0.28; the model is at the ceiling in 5 of 48 cells. What Reid raised in the meeting belongs here too: the model estimates status as a survey would measure it, and part of any between-country difference is survey difference (different years, seasons and teams). An earlier version of this work rested on one split and a baseline that had seen the answer; an audit found it and everything here is from the corrected protocol (docs/findings/TWO_READINGS_2026-09f.md, SANDBOX_LOG_2026-09.md).</a:t>
+              <a:t>The score is ranking accuracy: how closely the model’s order of districts matches the survey’s, from 0 to 1. One split on its own can move a result by 0.1, so everything is averaged over repeated splits. Plainer versions of the same accuracy are in the appendix: of the survey’s worst quarter of districts the model finds 43% (a random pick finds 25%), and it places a district in the correct WHO vitamin A band 64% of the time, within one band 92%. The ceiling: most districts hold one or two survey clusters, so the survey’s own district value is itself an estimate; from the variance components we can say what correlation a perfect predictor of the true district value could reach (variance_components_ceiling.csv, ceiling_vc). On the biomarker level the ceiling is about 0.56 and the model reaches 0.40; on prevalence 0.44 and 0.28; the model is at the ceiling in 5 of 48 cells. What Reid raised in the meeting belongs here too: the model estimates status as a survey would measure it, and part of any between-country difference is survey difference (different years, seasons and teams). An earlier version of this work rested on one split and a baseline that had seen the answer; an audit found it and everything here is from the corrected protocol (docs/findings/TWO_READINGS_2026-09f.md, SANDBOX_LOG_2026-09.md).</a:t>
             </a:r>
           </a:p>
         </p:txBody>
@@ -6052,7 +6052,7 @@
             <a:pPr lvl="0"/>
             <a:r>
               <a:rPr/>
-              <a:t>Of the truly worst quarter of districts, the model finds 43% inside a surveyed country and 41% in a country never seen. A random pick finds 25%.</a:t>
+              <a:t>Of the survey’s worst quarter of districts, the model finds 43% inside a surveyed country and 41% in a country never seen. A random pick finds 25%.</a:t>
             </a:r>
           </a:p>
           <a:p>
@@ -6471,7 +6471,7 @@
             </a:pPr>
             <a:r>
               <a:rPr/>
-              <a:t>Targeting the worst fifth of districts, the model finds the most deficiency</a:t>
+              <a:t>Targeting the model’s worst fifth reaches more deficient people</a:t>
             </a:r>
           </a:p>
         </p:txBody>
@@ -7837,7 +7837,7 @@
             <a:pPr lvl="0"/>
             <a:r>
               <a:rPr/>
-              <a:t>A big-data problem and a small-data problem at once: 454 public data layers for every district, but blood results for only 206 districts across four countries.</a:t>
+              <a:t>We have 454 public data layers for every district but blood results for only 206 districts in four countries, so this is a big-data and a small-data problem at once.</a:t>
             </a:r>
           </a:p>
           <a:p>
@@ -8016,7 +8016,7 @@
             <a:pPr lvl="0"/>
             <a:r>
               <a:rPr/>
-              <a:t>Chance is measured, not assumed: shuffling the outcome shows that a ranking reaches 0.08 with no information, on a scale of 0 to 1.</a:t>
+              <a:t>Shuffling the outcome measures chance: with no information at all a ranking still reaches 0.08 on a scale of 0 to 1.</a:t>
             </a:r>
           </a:p>
           <a:p>
@@ -8138,7 +8138,7 @@
             </a:pPr>
             <a:r>
               <a:rPr/>
-              <a:t>The broad pattern comes back. The fine detail does not.</a:t>
+              <a:t>In Ghana the model recovers the regional pattern but misplaces single districts</a:t>
             </a:r>
           </a:p>
         </p:txBody>
@@ -8283,7 +8283,7 @@
             </a:pPr>
             <a:r>
               <a:rPr/>
-              <a:t>Inside a country every method ties. Only ours works with no survey.</a:t>
+              <a:t>With a survey every method ties; without one only the proxy index can run</a:t>
             </a:r>
           </a:p>
         </p:txBody>

</xml_diff>

<commit_message>
Joint deck: the submitted abstract title on the title slide
Title-slide size in the Forum reference document set to 36pt so the full title fits; the brief notes where the title comes from.

Co-Authored-By: Claude Fable 5.1 <noreply@anthropic.com>
</commit_message>
<xml_diff>
--- a/docs/slides/MN-proxy-policy-deck-2026-09.pptx
+++ b/docs/slides/MN-proxy-policy-deck-2026-09.pptx
@@ -2178,7 +2178,7 @@
           <a:bodyPr anchor="b"/>
           <a:lstStyle>
             <a:lvl1pPr algn="ctr">
-              <a:defRPr sz="6000"/>
+              <a:defRPr sz="3600"/>
             </a:lvl1pPr>
           </a:lstStyle>
           <a:p>
@@ -5465,7 +5465,7 @@
             </a:pPr>
             <a:r>
               <a:rPr/>
-              <a:t>(Add submitted title)</a:t>
+              <a:t>Predicting Micronutrient Deficiency Prevalence in Sub-Saharan Africa Using Proxy Indicators: A Multi-country Machine Learning Framework</a:t>
             </a:r>
           </a:p>
         </p:txBody>

</xml_diff>

<commit_message>
Slop pass over the speaker notes of both decks
Joint deck: seven notes lose reader-guidance framings ("what the eye should take", "worth saying plainly", "the point of the project"), a label colon, a closing kicker and one "engineering, not research". Scientific deck: one contrast in the targeting note. The manuscript's version note and captions needed no change.

Co-Authored-By: Claude Fable 5.1 <noreply@anthropic.com>
</commit_message>
<xml_diff>
--- a/docs/slides/MN-proxy-policy-deck-2026-09.pptx
+++ b/docs/slides/MN-proxy-policy-deck-2026-09.pptx
@@ -790,7 +790,7 @@
             </a:pPr>
             <a:r>
               <a:rPr/>
-              <a:t>Source: results/tables/policy_deck/worst_fifth_probability.csv, script 07. The model was refitted on 40 different random splits, each district predicted with itself left out every time, and the map shows how often the district landed in the worst fifth. For child vitamin A in Ghana, 12 of 75 districts are in the worst fifth on at least 80 percent of refits and 56 on at most 20 percent; the middle is the uncertain part and should be treated as such. The black outlines are the survey’s own worst fifth. Across all countries and outcomes, districts the model puts at 80 percent or above are in the survey’s worst fifth 40% of the time, against 16% for districts at 20 percent or below and a base rate of 20 percent (worst_fifth_calibration.csv). The survey’s own worst fifth is noisy at one cluster per district, so 100 percent agreement is not the ceiling. This is the form a priority list should take: firm at the top, honest about the middle.</a:t>
+              <a:t>Source: results/tables/policy_deck/worst_fifth_probability.csv, script 07. The model was refitted on 40 different random splits, each district predicted with itself left out every time, and the map shows how often the district landed in the worst fifth. For child vitamin A in Ghana, 12 of 75 districts are in the worst fifth on at least 80 percent of refits and 56 on at most 20 percent; the middle is the uncertain part and should be treated as such. The black outlines are the survey’s own worst fifth. Across all countries and outcomes, districts the model puts at 80 percent or above are in the survey’s worst fifth 40% of the time, against 16% for districts at 20 percent or below and a base rate of 20 percent (worst_fifth_calibration.csv). The survey’s own worst fifth is noisy at one cluster per district, so 100 percent agreement is not the ceiling. A priority list should be shown this way, with the firm districts separated from the uncertain middle.</a:t>
             </a:r>
           </a:p>
         </p:txBody>
@@ -954,7 +954,7 @@
             </a:pPr>
             <a:r>
               <a:rPr/>
-              <a:t>Source: nce_targeting_summary.csv, in-fill, mean_capture over 24 combinations. Direct effort at the fifth of districts the model ranks worst and you reach 22% of the country’s deficient people; the survey’s own regional averages reach 20%, no information reaches 14%, and perfect knowledge would reach 47%. So the model closes about a fifth of the gap between guessing and knowing. Useful, and worth saying in exactly those terms. Likely question: why perfect knowledge captures only 47%. Burden is spread across districts; even the true worst fifth holds under half of it.</a:t>
+              <a:t>Source: nce_targeting_summary.csv, in-fill, mean_capture over 24 combinations. Direct effort at the fifth of districts the model ranks worst and you reach 22% of the country’s deficient people; the survey’s own regional averages reach 20%, no information reaches 14%, and perfect knowledge would reach 47%. So the model closes about a fifth of the gap between guessing and knowing. Likely question: why perfect knowledge captures only 47%. Burden is spread across districts; even the true worst fifth holds under half of it.</a:t>
             </a:r>
           </a:p>
         </p:txBody>
@@ -1036,7 +1036,7 @@
             </a:pPr>
             <a:r>
               <a:rPr/>
-              <a:t>Source: index_importance_top.csv, biomarker level, top five per outcome. The same picture recurs for all six outcomes: districts that are drier and grassier, less productive, more pastoral, poorer (fewer women owning their home or in paid work, less schooling) and with more stunted and underweight children rank worst on every deficiency we measured. That is the agro-ecology to diet to status pathway of the conceptual framework, seen from above. Two cautions to say aloud. First, these are not causes; a weight says where deficiency is, not what to change. Second, livestock density ranking positive for iron and B12 is ecological, not dietary: pastoral zones are the dry, poor zones. Nobody should leave the room thinking cattle cause iron deficiency. Colour groups the kind of data, not its strength. This slide and the next are the 3-minute short-oral talk.</a:t>
+              <a:t>Source: index_importance_top.csv, biomarker level, top five per outcome. The same picture recurs for all six outcomes: districts that are drier and grassier, less productive, more pastoral, poorer (fewer women owning their home or in paid work, less schooling) and with more stunted and underweight children rank worst on every deficiency we measured. That is the agro-ecology to diet to status pathway of the conceptual framework, seen from above. Two cautions to say aloud. First, these are not causes; a weight says where deficiency is, not what to change. Second, livestock density ranking positive for iron and B12 is ecological, not dietary: pastoral zones are the dry, poor zones. Nobody should leave the room thinking cattle cause iron deficiency. Colour marks the kind of data; bar length is the weight. This slide and the next are the 3-minute short-oral talk.</a:t>
             </a:r>
           </a:p>
         </p:txBody>
@@ -1774,7 +1774,7 @@
             </a:pPr>
             <a:r>
               <a:rPr/>
-              <a:t>Ghana, children’s vitamin A. Each district is predicted with itself removed from the model (5 folds, averaged over 10 repeats), so nothing in the middle map is fitted to the district it scores. Ranking accuracy 0.31 for this cell, against 0.08 for chance. What the eye should take: the north comes out as the worst region in both maps without the model being told anything about survey results. What it should not take: that any single district is correctly placed. The third map is the deployment case: the model fitted on all 75 surveyed districts and applied to every one of Ghana’s districts, so the grey gaps in the middle map are filled. Surveyed districts are in-sample in that panel; the honest check of the model is the middle panel. How firmly each district is placed is the appendix slide “How sure is the model about each district?”.</a:t>
+              <a:t>Ghana, children’s vitamin A. Each district is predicted with itself removed from the model (5 folds, averaged over 10 repeats), so nothing in the middle map is fitted to the district it scores. Ranking accuracy 0.31 for this cell, against 0.08 for chance. The north comes out as the worst region in both maps without the model being told anything about survey results; no single district should be read as correctly placed. The third map is the deployment case: the model fitted on all 75 surveyed districts and applied to every one of Ghana’s districts, so the grey gaps in the middle map are filled. Surveyed districts are in-sample in that panel; the honest check of the model is the middle panel. How firmly each district is placed is the appendix slide “How sure is the model about each district?”.</a:t>
             </a:r>
           </a:p>
         </p:txBody>
@@ -1856,7 +1856,7 @@
             </a:pPr>
             <a:r>
               <a:rPr/>
-              <a:t>Source: benchmarks_v2_summary.csv (biomarker level) and weight_sources_summary.csv for the twenty-layer composite. Read left to right. Inside a surveyed country, the proxy index (0.40), the neighbour smoother with covariates and the smoother alone are a three-way tie; differences under 0.03 are not differences here. Worth saying plainly: if you already have a survey, smoothing between neighbours gets you most of the way, and the survey’s own regional average reaches 0.31. The right-hand column is the point of the project. The smoothers and the regional average need survey data in the country; only the proxy methods produce anything at all there, at 0.26 to 0.37 against a chance level of 0.08, positive in 17 of 22 country-outcome combinations. Grey band: the 95th percentile of the permutation null (transport_null_calibration.csv). Rankings cross borders and absolute levels do not: raw ferritin differs several-fold between these surveys, so the model tells a new country which districts are worst, not how bad. The country with no survey we have actually ranked, Cote d’Ivoire, is in the appendix.</a:t>
+              <a:t>Source: benchmarks_v2_summary.csv (biomarker level) and weight_sources_summary.csv for the twenty-layer composite. Read left to right. Inside a surveyed country, the proxy index (0.40), the neighbour smoother with covariates and the smoother alone are a three-way tie; differences under 0.03 are not differences here. If you already have a survey, smoothing between neighbours gets you most of the way, and the survey’s own regional average reaches 0.31. The right-hand column is why the project exists: the smoothers and the regional average need survey data in the country, and only the proxy methods produce anything at all there, at 0.26 to 0.37 against a chance level of 0.08, positive in 17 of 22 country-outcome combinations. Grey band: the 95th percentile of the permutation null (transport_null_calibration.csv). Rankings cross borders and absolute levels do not: raw ferritin differs several-fold between these surveys, so the model tells a new country which districts are worst, not how bad. The country with no survey we have actually ranked, Cote d’Ivoire, is in the appendix.</a:t>
             </a:r>
           </a:p>
         </p:txBody>
@@ -1938,7 +1938,7 @@
             </a:pPr>
             <a:r>
               <a:rPr/>
-              <a:t>Source: training_country_curve.csv, proxy index, biomarker level, mean over held-out country-outcome combinations: 0.18 with one training country, 0.28 with three, and the curve has not flattened. This is the argument for pooling surveys across the region: a survey a country runs for itself improves every other country’s map. The feedback loop: the model says which districts are uncertain or likely worst, the next survey places clusters there, and the added survey sharpens the model for everyone. Third bullet from anchor_and_rank_summary.csv (AR-01): at 5 percent of a full sample, one national estimate plus the ranking gives a median district error of 10.3 percentage points, a regional survey of the same size 12.8 and a district survey 19.7; a district survey needs about a quarter of a full sample to match the anchored ranking. Say this cautiously: it is a design result on these four surveys, not a pilot. An index built only from climate and soil reaches 0.37 across districts and 0.45 across regions, better than the full index; that pair was chosen on these same four countries, so it is pre-registered for the next country rather than presented as a finding.</a:t>
+              <a:t>Source: training_country_curve.csv, proxy index, biomarker level, mean over held-out country-outcome combinations: 0.18 with one training country, 0.28 with three, and the curve has not flattened. This is the argument for pooling surveys across the region: a survey a country runs for itself improves every other country’s map. Surveys and models improve each other: the model says which districts are uncertain or likely worst, the next survey places clusters there, and the added survey sharpens the model for everyone. Third bullet from anchor_and_rank_summary.csv (AR-01): at 5 percent of a full sample, one national estimate plus the ranking gives a median district error of 10.3 percentage points, a regional survey of the same size 12.8 and a district survey 19.7; a district survey needs about a quarter of a full sample to match the anchored ranking. Say this cautiously: it is a design result on these four surveys, not a pilot. An index built only from climate and soil reaches 0.37 across districts and 0.45 across regions, better than the full index; that pair was chosen on these same four countries, so it is pre-registered for the next country rather than presented as a finding.</a:t>
             </a:r>
           </a:p>
         </p:txBody>
@@ -2102,7 +2102,7 @@
             </a:pPr>
             <a:r>
               <a:rPr/>
-              <a:t>Pre-registered predictions: docs/findings/PREREGISTRATION_NEW_COUNTRIES_2026-09.md. The product exists in pieces (the ranking, the probability map, the anchor-and-rank design, the geostatistical comparator on the cluster track); joining them is engineering, not research. Likely question: which country next. Any with a recent micronutrient survey and district identifiers; Tanzania’s 2010 module is already staged in the pipeline.</a:t>
+              <a:t>Pre-registered predictions: docs/findings/PREREGISTRATION_NEW_COUNTRIES_2026-09.md. The product exists in pieces (the ranking, the probability map, the anchor-and-rank design, the geostatistical comparator on the cluster track); joining them is an engineering job. Likely question: which country next. Any with a recent micronutrient survey and district identifiers; Tanzania’s 2010 module is already staged in the pipeline.</a:t>
             </a:r>
           </a:p>
         </p:txBody>

</xml_diff>